<commit_message>
feat: agregar reto extra de intercambio de entornos en clase de uv
Anade una nueva diapositiva a la presentacion de Entornos Virtuales
con un segundo ejercicio de equipo (20 min, rotando en salas de Zoom):
cada equipo exporta su pyproject.toml y uv.lock, se los pasa a otro
equipo, y este debe reconstruir el entorno ajeno solo con uv sync,
sin ver el codigo ni hacer preguntas.

Co-Authored-By: Claude Sonnet 5 <noreply@anthropic.com>
Claude-Session: https://claude.ai/code/session_01VLaj4RTwMrxAsK6UXCgNfF
</commit_message>
<xml_diff>
--- a/01-Intro-ML/clase-entornos-virtuales/01-Intro-ML-uv-Presentacion.pptx
+++ b/01-Intro-ML/clase-entornos-virtuales/01-Intro-ML-uv-Presentacion.pptx
@@ -15,9 +15,10 @@
     <p:sldId id="263" r:id="rId9"/>
     <p:sldId id="264" r:id="rId10"/>
     <p:sldId id="265" r:id="rId11"/>
+    <p:sldId id="266" r:id="rId12"/>
   </p:sldIdLst>
   <p:notesMasterIdLst>
-    <p:notesMasterId r:id="rId12"/>
+    <p:notesMasterId r:id="rId13"/>
   </p:notesMasterIdLst>
   <p:sldSz cx="12161520" cy="6858000"/>
   <p:notesSz cx="6858000" cy="12161520"/>
@@ -623,6 +624,94 @@
             <a:fld id="{F7021451-1387-4CA6-816F-3879F97B5CBC}" type="slidenum">
               <a:rPr lang="en-US"/>
               <a:t>10</a:t>
+            </a:fld>
+            <a:endParaRPr lang="en-US"/>
+          </a:p>
+        </p:txBody>
+      </p:sp>
+    </p:spTree>
+    <p:extLst>
+      <p:ext uri="{BB962C8B-B14F-4D97-AF65-F5344CB8AC3E}">
+        <p14:creationId xmlns:p14="http://schemas.microsoft.com/office/powerpoint/2010/main" val="1024086991"/>
+      </p:ext>
+    </p:extLst>
+  </p:cSld>
+  <p:clrMapOvr>
+    <a:masterClrMapping/>
+  </p:clrMapOvr>
+</p:notes>
+</file>
+
+<file path=ppt/notesSlides/notesSlide11.xml><?xml version="1.0" encoding="utf-8"?>
+<p:notes xmlns:a="http://schemas.openxmlformats.org/drawingml/2006/main" xmlns:r="http://schemas.openxmlformats.org/officeDocument/2006/relationships" xmlns:p="http://schemas.openxmlformats.org/presentationml/2006/main">
+  <p:cSld>
+    <p:spTree>
+      <p:nvGrpSpPr>
+        <p:cNvPr id="1" name=""/>
+        <p:cNvGrpSpPr/>
+        <p:nvPr/>
+      </p:nvGrpSpPr>
+      <p:grpSpPr>
+        <a:xfrm>
+          <a:off x="0" y="0"/>
+          <a:ext cx="0" cy="0"/>
+          <a:chOff x="0" y="0"/>
+          <a:chExt cx="0" cy="0"/>
+        </a:xfrm>
+      </p:grpSpPr>
+      <p:sp>
+        <p:nvSpPr>
+          <p:cNvPr id="2" name="Slide Image Placeholder 1"/>
+          <p:cNvSpPr>
+            <a:spLocks noGrp="1" noRot="1" noChangeAspect="1"/>
+          </p:cNvSpPr>
+          <p:nvPr>
+            <p:ph type="sldImg"/>
+          </p:nvPr>
+        </p:nvSpPr>
+        <p:spPr/>
+      </p:sp>
+      <p:sp>
+        <p:nvSpPr>
+          <p:cNvPr id="3" name="Notes Placeholder 2"/>
+          <p:cNvSpPr>
+            <a:spLocks noGrp="1"/>
+          </p:cNvSpPr>
+          <p:nvPr>
+            <p:ph type="body" idx="1"/>
+          </p:nvPr>
+        </p:nvSpPr>
+        <p:spPr/>
+        <p:txBody>
+          <a:bodyPr/>
+          <a:lstStyle/>
+          <a:p>
+            <a:r>
+              <a:rPr lang="en-US" dirty="0"/>
+              <a:t/>
+            </a:r>
+            <a:endParaRPr lang="en-US" dirty="0"/>
+          </a:p>
+        </p:txBody>
+      </p:sp>
+      <p:sp>
+        <p:nvSpPr>
+          <p:cNvPr id="4" name="Slide Number Placeholder 3"/>
+          <p:cNvSpPr>
+            <a:spLocks noGrp="1"/>
+          </p:cNvSpPr>
+          <p:nvPr>
+            <p:ph type="sldNum" sz="quarter" idx="10"/>
+          </p:nvPr>
+        </p:nvSpPr>
+        <p:spPr/>
+        <p:txBody>
+          <a:bodyPr/>
+          <a:lstStyle/>
+          <a:p>
+            <a:fld id="{F7021451-1387-4CA6-816F-3879F97B5CBC}" type="slidenum">
+              <a:rPr lang="en-US"/>
+              <a:t>11</a:t>
             </a:fld>
             <a:endParaRPr lang="en-US"/>
           </a:p>
@@ -1986,6 +2075,447 @@
       </p:grpSpPr>
       <p:sp>
         <p:nvSpPr>
+          <p:cNvPr id="2" name="Text 0"/>
+          <p:cNvSpPr txBox="1"/>
+          <p:nvPr/>
+        </p:nvSpPr>
+        <p:spPr>
+          <a:xfrm>
+            <a:off x="548640" y="164592"/>
+            <a:ext cx="8229600" cy="292608"/>
+          </a:xfrm>
+          <a:prstGeom prst="rect">
+            <a:avLst/>
+          </a:prstGeom>
+          <a:noFill/>
+          <a:ln/>
+        </p:spPr>
+        <p:txBody>
+          <a:bodyPr wrap="square" rtlCol="0" anchor="ctr"/>
+          <a:lstStyle/>
+          <a:p>
+            <a:pPr indent="0" marL="0">
+              <a:buNone/>
+            </a:pPr>
+            <a:r>
+              <a:rPr lang="en-US" sz="1200" b="1" spc="200" kern="0" dirty="0">
+                <a:solidFill>
+                  <a:srgbClr val="02C39A"/>
+                </a:solidFill>
+                <a:latin typeface="Calibri" pitchFamily="34" charset="0"/>
+                <a:ea typeface="Calibri" pitchFamily="34" charset="-122"/>
+                <a:cs typeface="Calibri" pitchFamily="34" charset="-120"/>
+              </a:rPr>
+              <a:t>RETO EXTRA · SI SOBRA TIEMPO</a:t>
+            </a:r>
+            <a:endParaRPr lang="en-US" sz="1200" dirty="0"/>
+          </a:p>
+        </p:txBody>
+      </p:sp>
+      <p:sp>
+        <p:nvSpPr>
+          <p:cNvPr id="3" name="Text 1"/>
+          <p:cNvSpPr txBox="1"/>
+          <p:nvPr/>
+        </p:nvSpPr>
+        <p:spPr>
+          <a:xfrm>
+            <a:off x="548640" y="411480"/>
+            <a:ext cx="11064240" cy="822960"/>
+          </a:xfrm>
+          <a:prstGeom prst="rect">
+            <a:avLst/>
+          </a:prstGeom>
+          <a:noFill/>
+          <a:ln/>
+        </p:spPr>
+        <p:txBody>
+          <a:bodyPr wrap="square" rtlCol="0" anchor="ctr"/>
+          <a:lstStyle/>
+          <a:p>
+            <a:pPr algn="l" indent="0" marL="0">
+              <a:buNone/>
+            </a:pPr>
+            <a:r>
+              <a:rPr lang="en-US" sz="3200" b="1" dirty="0">
+                <a:solidFill>
+                  <a:srgbClr val="FFFFFF"/>
+                </a:solidFill>
+                <a:latin typeface="Cambria" pitchFamily="34" charset="0"/>
+                <a:ea typeface="Cambria" pitchFamily="34" charset="-122"/>
+                <a:cs typeface="Cambria" pitchFamily="34" charset="-120"/>
+              </a:rPr>
+              <a:t>Intercambien entornos: ¿reconstruyen el ajeno?</a:t>
+            </a:r>
+            <a:endParaRPr lang="en-US" sz="3200" dirty="0"/>
+          </a:p>
+        </p:txBody>
+      </p:sp>
+      <p:sp>
+        <p:nvSpPr>
+          <p:cNvPr id="4" name="Text 2"/>
+          <p:cNvSpPr txBox="1"/>
+          <p:nvPr/>
+        </p:nvSpPr>
+        <p:spPr>
+          <a:xfrm>
+            <a:off x="640080" y="1417320"/>
+            <a:ext cx="10881360" cy="548640"/>
+          </a:xfrm>
+          <a:prstGeom prst="rect">
+            <a:avLst/>
+          </a:prstGeom>
+          <a:noFill/>
+          <a:ln/>
+        </p:spPr>
+        <p:txBody>
+          <a:bodyPr wrap="square" rtlCol="0" anchor="ctr"/>
+          <a:lstStyle/>
+          <a:p>
+            <a:pPr indent="0" marL="0">
+              <a:buNone/>
+            </a:pPr>
+            <a:r>
+              <a:rPr lang="en-US" sz="1500" i="1" dirty="0">
+                <a:solidFill>
+                  <a:srgbClr val="F4FBFA"/>
+                </a:solidFill>
+                <a:latin typeface="Calibri" pitchFamily="34" charset="0"/>
+                <a:ea typeface="Calibri" pitchFamily="34" charset="-122"/>
+                <a:cs typeface="Calibri" pitchFamily="34" charset="-120"/>
+              </a:rPr>
+              <a:t>La prueba real de "uv sync" no es reconstruir tu propio entorno: es reconstruir el de otro equipo, a ciegas.</a:t>
+            </a:r>
+            <a:endParaRPr lang="en-US" sz="1500" dirty="0"/>
+          </a:p>
+        </p:txBody>
+      </p:sp>
+      <p:sp>
+        <p:nvSpPr>
+          <p:cNvPr id="5" name="Shape 3"/>
+          <p:cNvSpPr/>
+          <p:nvPr/>
+        </p:nvSpPr>
+        <p:spPr>
+          <a:xfrm>
+            <a:off x="640080" y="2148840"/>
+            <a:ext cx="10881360" cy="3246120"/>
+          </a:xfrm>
+          <a:prstGeom prst="roundRect">
+            <a:avLst>
+              <a:gd name="adj" fmla="val 3380"/>
+            </a:avLst>
+          </a:prstGeom>
+          <a:solidFill>
+            <a:srgbClr val="0F4A50"/>
+          </a:solidFill>
+          <a:ln w="19050">
+            <a:solidFill>
+              <a:srgbClr val="02C39A"/>
+            </a:solidFill>
+            <a:prstDash val="solid"/>
+          </a:ln>
+        </p:spPr>
+      </p:sp>
+      <p:sp>
+        <p:nvSpPr>
+          <p:cNvPr id="6" name="Shape 4"/>
+          <p:cNvSpPr/>
+          <p:nvPr/>
+        </p:nvSpPr>
+        <p:spPr>
+          <a:xfrm>
+            <a:off x="914400" y="2377440"/>
+            <a:ext cx="594360" cy="594360"/>
+          </a:xfrm>
+          <a:prstGeom prst="ellipse">
+            <a:avLst/>
+          </a:prstGeom>
+          <a:solidFill>
+            <a:srgbClr val="02C39A"/>
+          </a:solidFill>
+          <a:ln/>
+        </p:spPr>
+      </p:sp>
+      <p:sp>
+        <p:nvSpPr>
+          <p:cNvPr id="7" name="Text 5"/>
+          <p:cNvSpPr txBox="1"/>
+          <p:nvPr/>
+        </p:nvSpPr>
+        <p:spPr>
+          <a:xfrm>
+            <a:off x="914400" y="2377440"/>
+            <a:ext cx="594360" cy="594360"/>
+          </a:xfrm>
+          <a:prstGeom prst="rect">
+            <a:avLst/>
+          </a:prstGeom>
+          <a:noFill/>
+          <a:ln/>
+        </p:spPr>
+        <p:txBody>
+          <a:bodyPr wrap="square" rtlCol="0" anchor="ctr"/>
+          <a:lstStyle/>
+          <a:p>
+            <a:pPr algn="ctr" indent="0" marL="0">
+              <a:buNone/>
+            </a:pPr>
+            <a:r>
+              <a:rPr lang="en-US" sz="1600" b="1" dirty="0">
+                <a:solidFill>
+                  <a:srgbClr val="0B3D42"/>
+                </a:solidFill>
+                <a:latin typeface="Cambria" pitchFamily="34" charset="0"/>
+                <a:ea typeface="Cambria" pitchFamily="34" charset="-122"/>
+                <a:cs typeface="Cambria" pitchFamily="34" charset="-120"/>
+              </a:rPr>
+              <a:t>20</a:t>
+            </a:r>
+            <a:endParaRPr lang="en-US" sz="1600" dirty="0"/>
+          </a:p>
+        </p:txBody>
+      </p:sp>
+      <p:sp>
+        <p:nvSpPr>
+          <p:cNvPr id="8" name="Text 6"/>
+          <p:cNvSpPr txBox="1"/>
+          <p:nvPr/>
+        </p:nvSpPr>
+        <p:spPr>
+          <a:xfrm>
+            <a:off x="1691640" y="2514600"/>
+            <a:ext cx="7315200" cy="457200"/>
+          </a:xfrm>
+          <a:prstGeom prst="rect">
+            <a:avLst/>
+          </a:prstGeom>
+          <a:noFill/>
+          <a:ln/>
+        </p:spPr>
+        <p:txBody>
+          <a:bodyPr wrap="square" rtlCol="0" anchor="ctr"/>
+          <a:lstStyle/>
+          <a:p>
+            <a:pPr indent="0" marL="0">
+              <a:buNone/>
+            </a:pPr>
+            <a:r>
+              <a:rPr lang="en-US" sz="1500" b="1" dirty="0">
+                <a:solidFill>
+                  <a:srgbClr val="02C39A"/>
+                </a:solidFill>
+                <a:latin typeface="Calibri" pitchFamily="34" charset="0"/>
+                <a:ea typeface="Calibri" pitchFamily="34" charset="-122"/>
+                <a:cs typeface="Calibri" pitchFamily="34" charset="-120"/>
+              </a:rPr>
+              <a:t>minutos, rotando entre salas de Zoom</a:t>
+            </a:r>
+            <a:endParaRPr lang="en-US" sz="1500" dirty="0"/>
+          </a:p>
+        </p:txBody>
+      </p:sp>
+      <p:sp>
+        <p:nvSpPr>
+          <p:cNvPr id="9" name="Text 7"/>
+          <p:cNvSpPr txBox="1"/>
+          <p:nvPr/>
+        </p:nvSpPr>
+        <p:spPr>
+          <a:xfrm>
+            <a:off x="914400" y="3246120"/>
+            <a:ext cx="10332720" cy="1920240"/>
+          </a:xfrm>
+          <a:prstGeom prst="rect">
+            <a:avLst/>
+          </a:prstGeom>
+          <a:noFill/>
+          <a:ln/>
+        </p:spPr>
+        <p:txBody>
+          <a:bodyPr wrap="square" rtlCol="0" anchor="ctr"/>
+          <a:lstStyle/>
+          <a:p>
+            <a:pPr marL="342900" indent="-342900">
+              <a:lnSpc>
+                <a:spcPts val="2800"/>
+              </a:lnSpc>
+              <a:buSzPct val="100000"/>
+              <a:buChar char="✦"/>
+            </a:pPr>
+            <a:r>
+              <a:rPr lang="en-US" sz="1500" dirty="0">
+                <a:solidFill>
+                  <a:srgbClr val="F4FBFA"/>
+                </a:solidFill>
+                <a:latin typeface="Calibri" pitchFamily="34" charset="0"/>
+                <a:ea typeface="Calibri" pitchFamily="34" charset="-122"/>
+                <a:cs typeface="Calibri" pitchFamily="34" charset="-120"/>
+              </a:rPr>
+              <a:t>Cada equipo exporta su pyproject.toml y uv.lock (los archivos, no explicaciones)</a:t>
+            </a:r>
+            <a:endParaRPr lang="en-US" sz="1500" dirty="0"/>
+          </a:p>
+          <a:p>
+            <a:pPr marL="342900" indent="-342900">
+              <a:lnSpc>
+                <a:spcPts val="2800"/>
+              </a:lnSpc>
+              <a:buSzPct val="100000"/>
+              <a:buChar char="✦"/>
+            </a:pPr>
+            <a:r>
+              <a:rPr lang="en-US" sz="1500" dirty="0">
+                <a:solidFill>
+                  <a:srgbClr val="F4FBFA"/>
+                </a:solidFill>
+                <a:latin typeface="Calibri" pitchFamily="34" charset="0"/>
+                <a:ea typeface="Calibri" pitchFamily="34" charset="-122"/>
+                <a:cs typeface="Calibri" pitchFamily="34" charset="-120"/>
+              </a:rPr>
+              <a:t>Se los pasan a otro equipo, rotando de sala</a:t>
+            </a:r>
+            <a:endParaRPr lang="en-US" sz="1500" dirty="0"/>
+          </a:p>
+          <a:p>
+            <a:pPr marL="342900" indent="-342900">
+              <a:lnSpc>
+                <a:spcPts val="2800"/>
+              </a:lnSpc>
+              <a:buSzPct val="100000"/>
+              <a:buChar char="✦"/>
+            </a:pPr>
+            <a:r>
+              <a:rPr lang="en-US" sz="1500" dirty="0">
+                <a:solidFill>
+                  <a:srgbClr val="F4FBFA"/>
+                </a:solidFill>
+                <a:latin typeface="Calibri" pitchFamily="34" charset="0"/>
+                <a:ea typeface="Calibri" pitchFamily="34" charset="-122"/>
+                <a:cs typeface="Calibri" pitchFamily="34" charset="-120"/>
+              </a:rPr>
+              <a:t>El equipo receptor reconstruye ese entorno solo con uv sync, sin preguntas ni ver el código</a:t>
+            </a:r>
+            <a:endParaRPr lang="en-US" sz="1500" dirty="0"/>
+          </a:p>
+          <a:p>
+            <a:pPr marL="342900" indent="-342900">
+              <a:lnSpc>
+                <a:spcPts val="2800"/>
+              </a:lnSpc>
+              <a:buSzPct val="100000"/>
+              <a:buChar char="✦"/>
+            </a:pPr>
+            <a:r>
+              <a:rPr lang="en-US" sz="1500" dirty="0">
+                <a:solidFill>
+                  <a:srgbClr val="F4FBFA"/>
+                </a:solidFill>
+                <a:latin typeface="Calibri" pitchFamily="34" charset="0"/>
+                <a:ea typeface="Calibri" pitchFamily="34" charset="-122"/>
+                <a:cs typeface="Calibri" pitchFamily="34" charset="-120"/>
+              </a:rPr>
+              <a:t>Gana el primer equipo que muestre la captura del entorno ajeno funcionando</a:t>
+            </a:r>
+            <a:endParaRPr lang="en-US" sz="1500" dirty="0"/>
+          </a:p>
+        </p:txBody>
+      </p:sp>
+      <p:sp>
+        <p:nvSpPr>
+          <p:cNvPr id="10" name="Shape 8"/>
+          <p:cNvSpPr/>
+          <p:nvPr/>
+        </p:nvSpPr>
+        <p:spPr>
+          <a:xfrm>
+            <a:off x="914400" y="5074920"/>
+            <a:ext cx="10332720" cy="457200"/>
+          </a:xfrm>
+          <a:prstGeom prst="roundRect">
+            <a:avLst>
+              <a:gd name="adj" fmla="val 50000"/>
+            </a:avLst>
+          </a:prstGeom>
+          <a:solidFill>
+            <a:srgbClr val="028090"/>
+          </a:solidFill>
+          <a:ln/>
+        </p:spPr>
+      </p:sp>
+      <p:sp>
+        <p:nvSpPr>
+          <p:cNvPr id="11" name="Text 9"/>
+          <p:cNvSpPr txBox="1"/>
+          <p:nvPr/>
+        </p:nvSpPr>
+        <p:spPr>
+          <a:xfrm>
+            <a:off x="914400" y="5074920"/>
+            <a:ext cx="10332720" cy="457200"/>
+          </a:xfrm>
+          <a:prstGeom prst="rect">
+            <a:avLst/>
+          </a:prstGeom>
+          <a:noFill/>
+          <a:ln/>
+        </p:spPr>
+        <p:txBody>
+          <a:bodyPr wrap="square" rtlCol="0" anchor="ctr"/>
+          <a:lstStyle/>
+          <a:p>
+            <a:pPr algn="ctr" indent="0" marL="0">
+              <a:buNone/>
+            </a:pPr>
+            <a:r>
+              <a:rPr lang="en-US" sz="1250" i="1" dirty="0">
+                <a:solidFill>
+                  <a:srgbClr val="FFFFFF"/>
+                </a:solidFill>
+                <a:latin typeface="Calibri" pitchFamily="34" charset="0"/>
+                <a:ea typeface="Calibri" pitchFamily="34" charset="-122"/>
+                <a:cs typeface="Calibri" pitchFamily="34" charset="-120"/>
+              </a:rPr>
+              <a:t>Si el otro equipo lo reconstruye igual a como tú lo veías, esa es la promesa de uv cumplida.</a:t>
+            </a:r>
+            <a:endParaRPr lang="en-US" sz="1250" dirty="0"/>
+          </a:p>
+        </p:txBody>
+      </p:sp>
+    </p:spTree>
+  </p:cSld>
+  <p:clrMapOvr>
+    <a:masterClrMapping/>
+  </p:clrMapOvr>
+</p:sld>
+</file>
+
+<file path=ppt/slides/slide11.xml><?xml version="1.0" encoding="utf-8"?>
+<p:sld xmlns:a="http://schemas.openxmlformats.org/drawingml/2006/main" xmlns:r="http://schemas.openxmlformats.org/officeDocument/2006/relationships" xmlns:p="http://schemas.openxmlformats.org/presentationml/2006/main">
+  <p:cSld name="Slide 11">
+    <p:bg>
+      <p:bgPr>
+        <a:solidFill>
+          <a:srgbClr val="0B3D42"/>
+        </a:solidFill>
+      </p:bgPr>
+    </p:bg>
+    <p:spTree>
+      <p:nvGrpSpPr>
+        <p:cNvPr id="1" name=""/>
+        <p:cNvGrpSpPr/>
+        <p:nvPr/>
+      </p:nvGrpSpPr>
+      <p:grpSpPr>
+        <a:xfrm>
+          <a:off x="0" y="0"/>
+          <a:ext cx="0" cy="0"/>
+          <a:chOff x="0" y="0"/>
+          <a:chExt cx="0" cy="0"/>
+        </a:xfrm>
+      </p:grpSpPr>
+      <p:sp>
+        <p:nvSpPr>
           <p:cNvPr id="2" name="Shape 0"/>
           <p:cNvSpPr/>
           <p:nvPr/>

</xml_diff>